<commit_message>
SPoC - Updated Diagram & Scenario 7
Updated the graphic to include DIS and DAS
Added a mixed DIS/DAS PoC ecosystem
</commit_message>
<xml_diff>
--- a/sources/vol1-diagram-use-case-spoc-tech-view.pptx
+++ b/sources/vol1-diagram-use-case-spoc-tech-view.pptx
@@ -8,7 +8,7 @@
     <p:notesMasterId r:id="rId3"/>
   </p:notesMasterIdLst>
   <p:sldIdLst>
-    <p:sldId id="280" r:id="rId2"/>
+    <p:sldId id="282" r:id="rId2"/>
   </p:sldIdLst>
   <p:sldSz cx="12192000" cy="6858000"/>
   <p:notesSz cx="6858000" cy="9144000"/>
@@ -246,7 +246,7 @@
       <p15:sldGuideLst xmlns:p15="http://schemas.microsoft.com/office/powerpoint/2012/main"/>
     </p:ext>
     <p:ext uri="http://customooxmlschemas.google.com/">
-      <go:slidesCustomData xmlns="" xmlns:mc="http://schemas.openxmlformats.org/markup-compatibility/2006" xmlns:mv="urn:schemas-microsoft-com:mac:vml" xmlns:c="http://schemas.openxmlformats.org/drawingml/2006/chart" xmlns:dgm="http://schemas.openxmlformats.org/drawingml/2006/diagram" xmlns:o="urn:schemas-microsoft-com:office:office" xmlns:v="urn:schemas-microsoft-com:vml" xmlns:pvml="urn:schemas-microsoft-com:office:powerpoint" xmlns:com="http://schemas.openxmlformats.org/drawingml/2006/compatibility" xmlns:p14="http://schemas.microsoft.com/office/powerpoint/2010/main" xmlns:p15="http://schemas.microsoft.com/office/powerpoint/2012/main" xmlns:ahyp="http://schemas.microsoft.com/office/drawing/2018/hyperlinkcolor" xmlns:go="http://customooxmlschemas.google.com/" r:id="rId21" roundtripDataSignature="AMtx7mioXqX06bVoM2NZpyvmQ4oN2c7f2Q=="/>
+      <go:slidesCustomData xmlns:go="http://customooxmlschemas.google.com/" xmlns:ahyp="http://schemas.microsoft.com/office/drawing/2018/hyperlinkcolor" xmlns:p15="http://schemas.microsoft.com/office/powerpoint/2012/main" xmlns:p14="http://schemas.microsoft.com/office/powerpoint/2010/main" xmlns:com="http://schemas.openxmlformats.org/drawingml/2006/compatibility" xmlns:pvml="urn:schemas-microsoft-com:office:powerpoint" xmlns:v="urn:schemas-microsoft-com:vml" xmlns:o="urn:schemas-microsoft-com:office:office" xmlns:dgm="http://schemas.openxmlformats.org/drawingml/2006/diagram" xmlns:c="http://schemas.openxmlformats.org/drawingml/2006/chart" xmlns:mv="urn:schemas-microsoft-com:mac:vml" xmlns:mc="http://schemas.openxmlformats.org/markup-compatibility/2006" xmlns="" r:id="rId21" roundtripDataSignature="AMtx7mioXqX06bVoM2NZpyvmQ4oN2c7f2Q=="/>
     </p:ext>
   </p:extLst>
 </p:presentation>
@@ -10246,6 +10246,40 @@
       </p:grpSpPr>
       <p:cxnSp>
         <p:nvCxnSpPr>
+          <p:cNvPr id="80" name="Google Shape;481;ga2bd4a1cd8_0_91">
+            <a:extLst>
+              <a:ext uri="{FF2B5EF4-FFF2-40B4-BE49-F238E27FC236}">
+                <a16:creationId xmlns:a16="http://schemas.microsoft.com/office/drawing/2014/main" id="{0B7043F8-44D1-408F-72B4-43CE5C870323}"/>
+              </a:ext>
+            </a:extLst>
+          </p:cNvPr>
+          <p:cNvCxnSpPr>
+            <a:cxnSpLocks/>
+          </p:cNvCxnSpPr>
+          <p:nvPr/>
+        </p:nvCxnSpPr>
+        <p:spPr>
+          <a:xfrm flipH="1" flipV="1">
+            <a:off x="5737120" y="1811374"/>
+            <a:ext cx="14134" cy="750707"/>
+          </a:xfrm>
+          <a:prstGeom prst="straightConnector1">
+            <a:avLst/>
+          </a:prstGeom>
+          <a:noFill/>
+          <a:ln w="28575" cap="flat" cmpd="sng">
+            <a:solidFill>
+              <a:srgbClr val="FF0000"/>
+            </a:solidFill>
+            <a:prstDash val="sysDot"/>
+            <a:round/>
+            <a:headEnd type="none" w="med" len="med"/>
+            <a:tailEnd type="none" w="med" len="med"/>
+          </a:ln>
+        </p:spPr>
+      </p:cxnSp>
+      <p:cxnSp>
+        <p:nvCxnSpPr>
           <p:cNvPr id="18" name="Google Shape;480;ga2bd4a1cd8_0_91">
             <a:extLst>
               <a:ext uri="{FF2B5EF4-FFF2-40B4-BE49-F238E27FC236}">
@@ -10394,7 +10428,7 @@
         </p:nvSpPr>
         <p:spPr>
           <a:xfrm>
-            <a:off x="3329225" y="4487546"/>
+            <a:off x="3006496" y="4969871"/>
             <a:ext cx="1578900" cy="338700"/>
           </a:xfrm>
           <a:prstGeom prst="rect">
@@ -10450,7 +10484,7 @@
         </p:nvSpPr>
         <p:spPr>
           <a:xfrm>
-            <a:off x="2558498" y="3905696"/>
+            <a:off x="3268594" y="4397533"/>
             <a:ext cx="961200" cy="466500"/>
           </a:xfrm>
           <a:prstGeom prst="rect">
@@ -10506,7 +10540,7 @@
         </p:nvSpPr>
         <p:spPr>
           <a:xfrm>
-            <a:off x="3701498" y="3905696"/>
+            <a:off x="4526495" y="4397533"/>
             <a:ext cx="823500" cy="466500"/>
           </a:xfrm>
           <a:prstGeom prst="rect">
@@ -10562,14 +10596,14 @@
         </p:nvSpPr>
         <p:spPr>
           <a:xfrm>
-            <a:off x="4692098" y="3905696"/>
+            <a:off x="1925737" y="4402247"/>
             <a:ext cx="961200" cy="466500"/>
           </a:xfrm>
           <a:prstGeom prst="rect">
             <a:avLst/>
           </a:prstGeom>
           <a:solidFill>
-            <a:srgbClr val="9FC5E8"/>
+            <a:srgbClr val="FF0000"/>
           </a:solidFill>
           <a:ln w="9525" cap="flat" cmpd="sng">
             <a:solidFill>
@@ -10597,10 +10631,18 @@
               <a:buNone/>
             </a:pPr>
             <a:r>
-              <a:rPr lang="en-US" dirty="0"/>
+              <a:rPr lang="en-US" dirty="0">
+                <a:solidFill>
+                  <a:schemeClr val="bg1"/>
+                </a:solidFill>
+              </a:rPr>
               <a:t>Ventilator</a:t>
             </a:r>
-            <a:endParaRPr dirty="0"/>
+            <a:endParaRPr dirty="0">
+              <a:solidFill>
+                <a:schemeClr val="bg1"/>
+              </a:solidFill>
+            </a:endParaRPr>
           </a:p>
         </p:txBody>
       </p:sp>
@@ -10620,7 +10662,7 @@
         </p:nvCxnSpPr>
         <p:spPr>
           <a:xfrm>
-            <a:off x="2604448" y="3289946"/>
+            <a:off x="2281719" y="3772271"/>
             <a:ext cx="7122089" cy="0"/>
           </a:xfrm>
           <a:prstGeom prst="straightConnector1">
@@ -10647,13 +10689,17 @@
               </a:ext>
             </a:extLst>
           </p:cNvPr>
-          <p:cNvCxnSpPr/>
+          <p:cNvCxnSpPr>
+            <a:cxnSpLocks/>
+            <a:stCxn id="26" idx="3"/>
+            <a:endCxn id="14" idx="1"/>
+          </p:cNvCxnSpPr>
           <p:nvPr/>
         </p:nvCxnSpPr>
         <p:spPr>
-          <a:xfrm rot="10800000">
-            <a:off x="3049148" y="3271396"/>
-            <a:ext cx="0" cy="630000"/>
+          <a:xfrm flipV="1">
+            <a:off x="2886937" y="4630783"/>
+            <a:ext cx="381657" cy="4714"/>
           </a:xfrm>
           <a:prstGeom prst="straightConnector1">
             <a:avLst/>
@@ -10661,9 +10707,9 @@
           <a:noFill/>
           <a:ln w="28575" cap="flat" cmpd="sng">
             <a:solidFill>
-              <a:schemeClr val="dk2"/>
+              <a:srgbClr val="FF0000"/>
             </a:solidFill>
-            <a:prstDash val="solid"/>
+            <a:prstDash val="sysDot"/>
             <a:round/>
             <a:headEnd type="none" w="med" len="med"/>
             <a:tailEnd type="none" w="med" len="med"/>
@@ -10686,7 +10732,7 @@
         </p:nvCxnSpPr>
         <p:spPr>
           <a:xfrm flipV="1">
-            <a:off x="4089496" y="3279721"/>
+            <a:off x="3766767" y="3762046"/>
             <a:ext cx="0" cy="640200"/>
           </a:xfrm>
           <a:prstGeom prst="straightConnector1">
@@ -10718,7 +10764,7 @@
         </p:nvCxnSpPr>
         <p:spPr>
           <a:xfrm rot="10800000">
-            <a:off x="5217023" y="3279721"/>
+            <a:off x="4894294" y="3762046"/>
             <a:ext cx="0" cy="640200"/>
           </a:xfrm>
           <a:prstGeom prst="straightConnector1">
@@ -10750,7 +10796,7 @@
         </p:nvSpPr>
         <p:spPr>
           <a:xfrm>
-            <a:off x="3595746" y="2925071"/>
+            <a:off x="3273017" y="3407396"/>
             <a:ext cx="2095200" cy="338700"/>
           </a:xfrm>
           <a:prstGeom prst="rect">
@@ -10806,7 +10852,7 @@
         </p:nvSpPr>
         <p:spPr>
           <a:xfrm>
-            <a:off x="7402464" y="4487546"/>
+            <a:off x="7079735" y="4969871"/>
             <a:ext cx="1578900" cy="338700"/>
           </a:xfrm>
           <a:prstGeom prst="rect">
@@ -10862,7 +10908,7 @@
         </p:nvSpPr>
         <p:spPr>
           <a:xfrm>
-            <a:off x="6631737" y="3905696"/>
+            <a:off x="6309008" y="4388021"/>
             <a:ext cx="961200" cy="466500"/>
           </a:xfrm>
           <a:prstGeom prst="rect">
@@ -10918,7 +10964,7 @@
         </p:nvSpPr>
         <p:spPr>
           <a:xfrm>
-            <a:off x="7774737" y="3905696"/>
+            <a:off x="7452008" y="4388021"/>
             <a:ext cx="823500" cy="466500"/>
           </a:xfrm>
           <a:prstGeom prst="rect">
@@ -10974,7 +11020,7 @@
         </p:nvSpPr>
         <p:spPr>
           <a:xfrm>
-            <a:off x="8765337" y="3905696"/>
+            <a:off x="8442608" y="4388021"/>
             <a:ext cx="961200" cy="466500"/>
           </a:xfrm>
           <a:prstGeom prst="rect">
@@ -11030,7 +11076,7 @@
         </p:nvCxnSpPr>
         <p:spPr>
           <a:xfrm rot="10800000">
-            <a:off x="7122387" y="3271396"/>
+            <a:off x="6799658" y="3753721"/>
             <a:ext cx="0" cy="630000"/>
           </a:xfrm>
           <a:prstGeom prst="straightConnector1">
@@ -11064,7 +11110,7 @@
         </p:nvCxnSpPr>
         <p:spPr>
           <a:xfrm flipV="1">
-            <a:off x="8162735" y="3279721"/>
+            <a:off x="7840006" y="3762046"/>
             <a:ext cx="0" cy="640200"/>
           </a:xfrm>
           <a:prstGeom prst="straightConnector1">
@@ -11096,7 +11142,7 @@
         </p:nvCxnSpPr>
         <p:spPr>
           <a:xfrm rot="10800000">
-            <a:off x="9290262" y="3279721"/>
+            <a:off x="8967533" y="3762046"/>
             <a:ext cx="0" cy="640200"/>
           </a:xfrm>
           <a:prstGeom prst="straightConnector1">
@@ -11130,7 +11176,7 @@
         </p:nvCxnSpPr>
         <p:spPr>
           <a:xfrm flipV="1">
-            <a:off x="6119545" y="1297603"/>
+            <a:off x="5796816" y="1779928"/>
             <a:ext cx="0" cy="2002569"/>
           </a:xfrm>
           <a:prstGeom prst="straightConnector1">
@@ -11162,7 +11208,7 @@
         </p:nvSpPr>
         <p:spPr>
           <a:xfrm>
-            <a:off x="2090057" y="2595624"/>
+            <a:off x="1767328" y="3077949"/>
             <a:ext cx="3851564" cy="2422566"/>
           </a:xfrm>
           <a:prstGeom prst="rect">
@@ -11212,7 +11258,7 @@
         </p:nvSpPr>
         <p:spPr>
           <a:xfrm>
-            <a:off x="6341423" y="2595624"/>
+            <a:off x="6018694" y="3077949"/>
             <a:ext cx="3851564" cy="2422566"/>
           </a:xfrm>
           <a:prstGeom prst="rect">
@@ -11262,7 +11308,7 @@
         </p:nvSpPr>
         <p:spPr>
           <a:xfrm>
-            <a:off x="5493184" y="1917447"/>
+            <a:off x="5170455" y="2399772"/>
             <a:ext cx="1219200" cy="466500"/>
           </a:xfrm>
           <a:prstGeom prst="rect">
@@ -11320,7 +11366,7 @@
         </p:nvCxnSpPr>
         <p:spPr>
           <a:xfrm flipV="1">
-            <a:off x="8424260" y="1297603"/>
+            <a:off x="8101531" y="1779928"/>
             <a:ext cx="0" cy="615589"/>
           </a:xfrm>
           <a:prstGeom prst="straightConnector1">
@@ -11354,7 +11400,7 @@
         </p:nvCxnSpPr>
         <p:spPr>
           <a:xfrm>
-            <a:off x="4692098" y="1297603"/>
+            <a:off x="4369369" y="1779928"/>
             <a:ext cx="4362130" cy="0"/>
           </a:xfrm>
           <a:prstGeom prst="straightConnector1">
@@ -11390,7 +11436,7 @@
         </p:nvCxnSpPr>
         <p:spPr>
           <a:xfrm flipV="1">
-            <a:off x="6712384" y="2147062"/>
+            <a:off x="6389655" y="2629387"/>
             <a:ext cx="421064" cy="3635"/>
           </a:xfrm>
           <a:prstGeom prst="straightConnector1">
@@ -11429,7 +11475,7 @@
         </p:nvSpPr>
         <p:spPr>
           <a:xfrm>
-            <a:off x="7133448" y="1913812"/>
+            <a:off x="6810719" y="2396137"/>
             <a:ext cx="1908995" cy="466500"/>
           </a:xfrm>
           <a:prstGeom prst="rect">
@@ -11485,8 +11531,8 @@
         </p:nvSpPr>
         <p:spPr>
           <a:xfrm>
-            <a:off x="1707782" y="1552576"/>
-            <a:ext cx="9311764" cy="3899641"/>
+            <a:off x="3110753" y="2034901"/>
+            <a:ext cx="7586064" cy="3899641"/>
           </a:xfrm>
           <a:prstGeom prst="rect">
             <a:avLst/>
@@ -11494,7 +11540,9 @@
           <a:noFill/>
           <a:ln>
             <a:solidFill>
-              <a:srgbClr val="FF0000"/>
+              <a:schemeClr val="accent6">
+                <a:lumMod val="75000"/>
+              </a:schemeClr>
             </a:solidFill>
             <a:prstDash val="dash"/>
           </a:ln>
@@ -11544,8 +11592,8 @@
         </p:nvSpPr>
         <p:spPr>
           <a:xfrm>
-            <a:off x="2144084" y="5115667"/>
-            <a:ext cx="1578900" cy="338700"/>
+            <a:off x="3110753" y="2098764"/>
+            <a:ext cx="852329" cy="463317"/>
           </a:xfrm>
           <a:prstGeom prst="rect">
             <a:avLst/>
@@ -11571,9 +11619,11 @@
               <a:buNone/>
             </a:pPr>
             <a:r>
-              <a:rPr lang="en-US" sz="1600" dirty="0">
+              <a:rPr lang="en-US" sz="2400" b="1" dirty="0">
                 <a:solidFill>
-                  <a:srgbClr val="FF0000"/>
+                  <a:schemeClr val="accent6">
+                    <a:lumMod val="75000"/>
+                  </a:schemeClr>
                 </a:solidFill>
                 <a:latin typeface="Calibri"/>
                 <a:ea typeface="Calibri"/>
@@ -11582,9 +11632,11 @@
               </a:rPr>
               <a:t>DAS</a:t>
             </a:r>
-            <a:endParaRPr dirty="0">
+            <a:endParaRPr sz="2000" b="1" dirty="0">
               <a:solidFill>
-                <a:srgbClr val="FF0000"/>
+                <a:schemeClr val="accent6">
+                  <a:lumMod val="75000"/>
+                </a:schemeClr>
               </a:solidFill>
             </a:endParaRPr>
           </a:p>
@@ -11604,7 +11656,7 @@
         </p:nvSpPr>
         <p:spPr>
           <a:xfrm>
-            <a:off x="1940798" y="4602896"/>
+            <a:off x="1618069" y="5085221"/>
             <a:ext cx="1578900" cy="338700"/>
           </a:xfrm>
           <a:prstGeom prst="rect">
@@ -11664,7 +11716,7 @@
         </p:nvSpPr>
         <p:spPr>
           <a:xfrm>
-            <a:off x="8740158" y="4670887"/>
+            <a:off x="8417429" y="5153212"/>
             <a:ext cx="1578900" cy="338700"/>
           </a:xfrm>
           <a:prstGeom prst="rect">
@@ -11710,10 +11762,966 @@
           </a:p>
         </p:txBody>
       </p:sp>
+      <p:sp>
+        <p:nvSpPr>
+          <p:cNvPr id="3" name="Rectangle 2">
+            <a:extLst>
+              <a:ext uri="{FF2B5EF4-FFF2-40B4-BE49-F238E27FC236}">
+                <a16:creationId xmlns:a16="http://schemas.microsoft.com/office/drawing/2014/main" id="{EB52EFF3-7D72-0CFF-4A57-5B722B261E16}"/>
+              </a:ext>
+            </a:extLst>
+          </p:cNvPr>
+          <p:cNvSpPr/>
+          <p:nvPr/>
+        </p:nvSpPr>
+        <p:spPr>
+          <a:xfrm>
+            <a:off x="1326777" y="715409"/>
+            <a:ext cx="9814739" cy="5504328"/>
+          </a:xfrm>
+          <a:prstGeom prst="rect">
+            <a:avLst/>
+          </a:prstGeom>
+          <a:noFill/>
+          <a:ln>
+            <a:solidFill>
+              <a:srgbClr val="FF0000"/>
+            </a:solidFill>
+            <a:prstDash val="dash"/>
+          </a:ln>
+        </p:spPr>
+        <p:style>
+          <a:lnRef idx="2">
+            <a:schemeClr val="accent1">
+              <a:shade val="50000"/>
+            </a:schemeClr>
+          </a:lnRef>
+          <a:fillRef idx="1">
+            <a:schemeClr val="accent1"/>
+          </a:fillRef>
+          <a:effectRef idx="0">
+            <a:schemeClr val="accent1"/>
+          </a:effectRef>
+          <a:fontRef idx="minor">
+            <a:schemeClr val="lt1"/>
+          </a:fontRef>
+        </p:style>
+        <p:txBody>
+          <a:bodyPr rtlCol="0" anchor="ctr"/>
+          <a:lstStyle/>
+          <a:p>
+            <a:pPr algn="ctr"/>
+            <a:endParaRPr lang="en-US">
+              <a:ln w="38100">
+                <a:solidFill>
+                  <a:srgbClr val="FF0000"/>
+                </a:solidFill>
+              </a:ln>
+            </a:endParaRPr>
+          </a:p>
+        </p:txBody>
+      </p:sp>
+      <p:sp>
+        <p:nvSpPr>
+          <p:cNvPr id="5" name="Google Shape;463;ga2bd4a1cd8_0_91">
+            <a:extLst>
+              <a:ext uri="{FF2B5EF4-FFF2-40B4-BE49-F238E27FC236}">
+                <a16:creationId xmlns:a16="http://schemas.microsoft.com/office/drawing/2014/main" id="{ABF59064-5ECB-04DF-A497-8935D70A053B}"/>
+              </a:ext>
+            </a:extLst>
+          </p:cNvPr>
+          <p:cNvSpPr txBox="1"/>
+          <p:nvPr/>
+        </p:nvSpPr>
+        <p:spPr>
+          <a:xfrm>
+            <a:off x="1391863" y="885928"/>
+            <a:ext cx="930866" cy="338700"/>
+          </a:xfrm>
+          <a:prstGeom prst="rect">
+            <a:avLst/>
+          </a:prstGeom>
+          <a:noFill/>
+          <a:ln>
+            <a:noFill/>
+          </a:ln>
+        </p:spPr>
+        <p:txBody>
+          <a:bodyPr spcFirstLastPara="1" wrap="square" lIns="91425" tIns="45700" rIns="91425" bIns="45700" anchor="t" anchorCtr="0">
+            <a:noAutofit/>
+          </a:bodyPr>
+          <a:lstStyle/>
+          <a:p>
+            <a:pPr marL="0" marR="0" lvl="0" indent="0" algn="ctr" rtl="0">
+              <a:spcBef>
+                <a:spcPts val="0"/>
+              </a:spcBef>
+              <a:spcAft>
+                <a:spcPts val="0"/>
+              </a:spcAft>
+              <a:buNone/>
+            </a:pPr>
+            <a:r>
+              <a:rPr lang="en-US" sz="2400" b="1" dirty="0">
+                <a:solidFill>
+                  <a:srgbClr val="FF0000"/>
+                </a:solidFill>
+                <a:latin typeface="Calibri"/>
+                <a:ea typeface="Calibri"/>
+                <a:cs typeface="Calibri"/>
+                <a:sym typeface="Calibri"/>
+              </a:rPr>
+              <a:t>DIS</a:t>
+            </a:r>
+            <a:endParaRPr sz="2400" b="1" dirty="0">
+              <a:solidFill>
+                <a:srgbClr val="FF0000"/>
+              </a:solidFill>
+            </a:endParaRPr>
+          </a:p>
+        </p:txBody>
+      </p:sp>
+      <p:grpSp>
+        <p:nvGrpSpPr>
+          <p:cNvPr id="6" name="Group 5">
+            <a:extLst>
+              <a:ext uri="{FF2B5EF4-FFF2-40B4-BE49-F238E27FC236}">
+                <a16:creationId xmlns:a16="http://schemas.microsoft.com/office/drawing/2014/main" id="{F8E341A7-7259-8538-089B-F5BF39271A48}"/>
+              </a:ext>
+            </a:extLst>
+          </p:cNvPr>
+          <p:cNvGrpSpPr/>
+          <p:nvPr/>
+        </p:nvGrpSpPr>
+        <p:grpSpPr>
+          <a:xfrm>
+            <a:off x="8049262" y="998222"/>
+            <a:ext cx="1639984" cy="488169"/>
+            <a:chOff x="7513976" y="2934003"/>
+            <a:chExt cx="1639984" cy="488169"/>
+          </a:xfrm>
+        </p:grpSpPr>
+        <p:sp>
+          <p:nvSpPr>
+            <p:cNvPr id="7" name="Google Shape;466;ga2bd4a1cd8_0_91">
+              <a:extLst>
+                <a:ext uri="{FF2B5EF4-FFF2-40B4-BE49-F238E27FC236}">
+                  <a16:creationId xmlns:a16="http://schemas.microsoft.com/office/drawing/2014/main" id="{7279B40E-4AB2-FCEC-C862-1564477CDC75}"/>
+                </a:ext>
+              </a:extLst>
+            </p:cNvPr>
+            <p:cNvSpPr/>
+            <p:nvPr/>
+          </p:nvSpPr>
+          <p:spPr>
+            <a:xfrm>
+              <a:off x="7513976" y="2955672"/>
+              <a:ext cx="1509401" cy="466500"/>
+            </a:xfrm>
+            <a:prstGeom prst="rect">
+              <a:avLst/>
+            </a:prstGeom>
+            <a:solidFill>
+              <a:srgbClr val="A4C2F4"/>
+            </a:solidFill>
+            <a:ln w="9525" cap="flat" cmpd="sng">
+              <a:solidFill>
+                <a:srgbClr val="000000"/>
+              </a:solidFill>
+              <a:prstDash val="solid"/>
+              <a:round/>
+              <a:headEnd type="none" w="sm" len="sm"/>
+              <a:tailEnd type="none" w="sm" len="sm"/>
+            </a:ln>
+          </p:spPr>
+          <p:txBody>
+            <a:bodyPr spcFirstLastPara="1" wrap="square" lIns="91425" tIns="91425" rIns="91425" bIns="91425" anchor="ctr" anchorCtr="0">
+              <a:noAutofit/>
+            </a:bodyPr>
+            <a:lstStyle/>
+            <a:p>
+              <a:pPr marL="0" lvl="0" indent="0" algn="ctr" rtl="0">
+                <a:spcBef>
+                  <a:spcPts val="0"/>
+                </a:spcBef>
+                <a:spcAft>
+                  <a:spcPts val="0"/>
+                </a:spcAft>
+                <a:buNone/>
+              </a:pPr>
+              <a:r>
+                <a:rPr lang="en-US" dirty="0"/>
+                <a:t>Clinician </a:t>
+              </a:r>
+              <a:r>
+                <a:rPr lang="en-US" dirty="0" err="1"/>
+                <a:t>Notific</a:t>
+              </a:r>
+              <a:r>
+                <a:rPr lang="en-US" dirty="0"/>
+                <a:t>. System</a:t>
+              </a:r>
+              <a:endParaRPr dirty="0"/>
+            </a:p>
+          </p:txBody>
+        </p:sp>
+        <p:sp>
+          <p:nvSpPr>
+            <p:cNvPr id="9" name="Lightning Bolt 8">
+              <a:extLst>
+                <a:ext uri="{FF2B5EF4-FFF2-40B4-BE49-F238E27FC236}">
+                  <a16:creationId xmlns:a16="http://schemas.microsoft.com/office/drawing/2014/main" id="{E2825884-892F-0FF4-2EF2-C2C413343391}"/>
+                </a:ext>
+              </a:extLst>
+            </p:cNvPr>
+            <p:cNvSpPr/>
+            <p:nvPr/>
+          </p:nvSpPr>
+          <p:spPr>
+            <a:xfrm>
+              <a:off x="8959097" y="2934003"/>
+              <a:ext cx="194863" cy="394089"/>
+            </a:xfrm>
+            <a:prstGeom prst="lightningBolt">
+              <a:avLst/>
+            </a:prstGeom>
+          </p:spPr>
+          <p:style>
+            <a:lnRef idx="2">
+              <a:schemeClr val="accent1">
+                <a:shade val="50000"/>
+              </a:schemeClr>
+            </a:lnRef>
+            <a:fillRef idx="1">
+              <a:schemeClr val="accent1"/>
+            </a:fillRef>
+            <a:effectRef idx="0">
+              <a:schemeClr val="accent1"/>
+            </a:effectRef>
+            <a:fontRef idx="minor">
+              <a:schemeClr val="lt1"/>
+            </a:fontRef>
+          </p:style>
+          <p:txBody>
+            <a:bodyPr rtlCol="0" anchor="ctr"/>
+            <a:lstStyle/>
+            <a:p>
+              <a:pPr algn="ctr"/>
+              <a:endParaRPr lang="en-US"/>
+            </a:p>
+          </p:txBody>
+        </p:sp>
+      </p:grpSp>
+      <p:grpSp>
+        <p:nvGrpSpPr>
+          <p:cNvPr id="10" name="Group 9">
+            <a:extLst>
+              <a:ext uri="{FF2B5EF4-FFF2-40B4-BE49-F238E27FC236}">
+                <a16:creationId xmlns:a16="http://schemas.microsoft.com/office/drawing/2014/main" id="{D4E019F6-047C-7D50-8AD0-318704766AB8}"/>
+              </a:ext>
+            </a:extLst>
+          </p:cNvPr>
+          <p:cNvGrpSpPr/>
+          <p:nvPr/>
+        </p:nvGrpSpPr>
+        <p:grpSpPr>
+          <a:xfrm>
+            <a:off x="10001552" y="898480"/>
+            <a:ext cx="918028" cy="862166"/>
+            <a:chOff x="9434570" y="1690825"/>
+            <a:chExt cx="1953880" cy="1768165"/>
+          </a:xfrm>
+        </p:grpSpPr>
+        <p:pic>
+          <p:nvPicPr>
+            <p:cNvPr id="11" name="Picture 2" descr="IPhone Smartphone Clip Art, PNG, 884x1552px, Iphone, Android, Cellular  Network, Communication, Communication Device Download Free">
+              <a:extLst>
+                <a:ext uri="{FF2B5EF4-FFF2-40B4-BE49-F238E27FC236}">
+                  <a16:creationId xmlns:a16="http://schemas.microsoft.com/office/drawing/2014/main" id="{1F57B682-9A40-C1F6-EC11-2A141A716537}"/>
+                </a:ext>
+              </a:extLst>
+            </p:cNvPr>
+            <p:cNvPicPr>
+              <a:picLocks noChangeAspect="1" noChangeArrowheads="1"/>
+            </p:cNvPicPr>
+            <p:nvPr/>
+          </p:nvPicPr>
+          <p:blipFill>
+            <a:blip r:embed="rId3">
+              <a:extLst>
+                <a:ext uri="{28A0092B-C50C-407E-A947-70E740481C1C}">
+                  <a14:useLocalDpi xmlns:a14="http://schemas.microsoft.com/office/drawing/2010/main" val="0"/>
+                </a:ext>
+              </a:extLst>
+            </a:blip>
+            <a:srcRect/>
+            <a:stretch>
+              <a:fillRect/>
+            </a:stretch>
+          </p:blipFill>
+          <p:spPr bwMode="auto">
+            <a:xfrm>
+              <a:off x="9778362" y="1902502"/>
+              <a:ext cx="550310" cy="965613"/>
+            </a:xfrm>
+            <a:prstGeom prst="rect">
+              <a:avLst/>
+            </a:prstGeom>
+            <a:noFill/>
+            <a:extLst>
+              <a:ext uri="{909E8E84-426E-40DD-AFC4-6F175D3DCCD1}">
+                <a14:hiddenFill xmlns:a14="http://schemas.microsoft.com/office/drawing/2010/main">
+                  <a:solidFill>
+                    <a:srgbClr val="FFFFFF"/>
+                  </a:solidFill>
+                </a14:hiddenFill>
+              </a:ext>
+            </a:extLst>
+          </p:spPr>
+        </p:pic>
+        <p:pic>
+          <p:nvPicPr>
+            <p:cNvPr id="12" name="Picture 2" descr="IPhone Smartphone Clip Art, PNG, 884x1552px, Iphone, Android, Cellular  Network, Communication, Communication Device Download Free">
+              <a:extLst>
+                <a:ext uri="{FF2B5EF4-FFF2-40B4-BE49-F238E27FC236}">
+                  <a16:creationId xmlns:a16="http://schemas.microsoft.com/office/drawing/2014/main" id="{B13A3FA6-7A14-3551-21B3-3E1D9BB9C77A}"/>
+                </a:ext>
+              </a:extLst>
+            </p:cNvPr>
+            <p:cNvPicPr>
+              <a:picLocks noChangeAspect="1" noChangeArrowheads="1"/>
+            </p:cNvPicPr>
+            <p:nvPr/>
+          </p:nvPicPr>
+          <p:blipFill>
+            <a:blip r:embed="rId3">
+              <a:extLst>
+                <a:ext uri="{28A0092B-C50C-407E-A947-70E740481C1C}">
+                  <a14:useLocalDpi xmlns:a14="http://schemas.microsoft.com/office/drawing/2010/main" val="0"/>
+                </a:ext>
+              </a:extLst>
+            </a:blip>
+            <a:srcRect/>
+            <a:stretch>
+              <a:fillRect/>
+            </a:stretch>
+          </p:blipFill>
+          <p:spPr bwMode="auto">
+            <a:xfrm>
+              <a:off x="9930762" y="2054902"/>
+              <a:ext cx="550310" cy="965613"/>
+            </a:xfrm>
+            <a:prstGeom prst="rect">
+              <a:avLst/>
+            </a:prstGeom>
+            <a:noFill/>
+            <a:extLst>
+              <a:ext uri="{909E8E84-426E-40DD-AFC4-6F175D3DCCD1}">
+                <a14:hiddenFill xmlns:a14="http://schemas.microsoft.com/office/drawing/2010/main">
+                  <a:solidFill>
+                    <a:srgbClr val="FFFFFF"/>
+                  </a:solidFill>
+                </a14:hiddenFill>
+              </a:ext>
+            </a:extLst>
+          </p:spPr>
+        </p:pic>
+        <p:pic>
+          <p:nvPicPr>
+            <p:cNvPr id="15" name="Picture 2" descr="IPhone Smartphone Clip Art, PNG, 884x1552px, Iphone, Android, Cellular  Network, Communication, Communication Device Download Free">
+              <a:extLst>
+                <a:ext uri="{FF2B5EF4-FFF2-40B4-BE49-F238E27FC236}">
+                  <a16:creationId xmlns:a16="http://schemas.microsoft.com/office/drawing/2014/main" id="{940F3537-A804-2301-B985-2D33C9BBCC40}"/>
+                </a:ext>
+              </a:extLst>
+            </p:cNvPr>
+            <p:cNvPicPr>
+              <a:picLocks noChangeAspect="1" noChangeArrowheads="1"/>
+            </p:cNvPicPr>
+            <p:nvPr/>
+          </p:nvPicPr>
+          <p:blipFill>
+            <a:blip r:embed="rId3">
+              <a:extLst>
+                <a:ext uri="{28A0092B-C50C-407E-A947-70E740481C1C}">
+                  <a14:useLocalDpi xmlns:a14="http://schemas.microsoft.com/office/drawing/2010/main" val="0"/>
+                </a:ext>
+              </a:extLst>
+            </a:blip>
+            <a:srcRect/>
+            <a:stretch>
+              <a:fillRect/>
+            </a:stretch>
+          </p:blipFill>
+          <p:spPr bwMode="auto">
+            <a:xfrm>
+              <a:off x="10083162" y="2207302"/>
+              <a:ext cx="550310" cy="965613"/>
+            </a:xfrm>
+            <a:prstGeom prst="rect">
+              <a:avLst/>
+            </a:prstGeom>
+            <a:noFill/>
+            <a:extLst>
+              <a:ext uri="{909E8E84-426E-40DD-AFC4-6F175D3DCCD1}">
+                <a14:hiddenFill xmlns:a14="http://schemas.microsoft.com/office/drawing/2010/main">
+                  <a:solidFill>
+                    <a:srgbClr val="FFFFFF"/>
+                  </a:solidFill>
+                </a14:hiddenFill>
+              </a:ext>
+            </a:extLst>
+          </p:spPr>
+        </p:pic>
+        <p:pic>
+          <p:nvPicPr>
+            <p:cNvPr id="16" name="Picture 2" descr="IPhone Smartphone Clip Art, PNG, 884x1552px, Iphone, Android, Cellular  Network, Communication, Communication Device Download Free">
+              <a:extLst>
+                <a:ext uri="{FF2B5EF4-FFF2-40B4-BE49-F238E27FC236}">
+                  <a16:creationId xmlns:a16="http://schemas.microsoft.com/office/drawing/2014/main" id="{211AA7B0-5D79-F279-0260-E8BDCBFA4784}"/>
+                </a:ext>
+              </a:extLst>
+            </p:cNvPr>
+            <p:cNvPicPr>
+              <a:picLocks noChangeAspect="1" noChangeArrowheads="1"/>
+            </p:cNvPicPr>
+            <p:nvPr/>
+          </p:nvPicPr>
+          <p:blipFill>
+            <a:blip r:embed="rId3">
+              <a:extLst>
+                <a:ext uri="{28A0092B-C50C-407E-A947-70E740481C1C}">
+                  <a14:useLocalDpi xmlns:a14="http://schemas.microsoft.com/office/drawing/2010/main" val="0"/>
+                </a:ext>
+              </a:extLst>
+            </a:blip>
+            <a:srcRect/>
+            <a:stretch>
+              <a:fillRect/>
+            </a:stretch>
+          </p:blipFill>
+          <p:spPr bwMode="auto">
+            <a:xfrm>
+              <a:off x="10235562" y="2359702"/>
+              <a:ext cx="550310" cy="965613"/>
+            </a:xfrm>
+            <a:prstGeom prst="rect">
+              <a:avLst/>
+            </a:prstGeom>
+            <a:noFill/>
+            <a:extLst>
+              <a:ext uri="{909E8E84-426E-40DD-AFC4-6F175D3DCCD1}">
+                <a14:hiddenFill xmlns:a14="http://schemas.microsoft.com/office/drawing/2010/main">
+                  <a:solidFill>
+                    <a:srgbClr val="FFFFFF"/>
+                  </a:solidFill>
+                </a14:hiddenFill>
+              </a:ext>
+            </a:extLst>
+          </p:spPr>
+        </p:pic>
+        <p:sp>
+          <p:nvSpPr>
+            <p:cNvPr id="19" name="Lightning Bolt 18">
+              <a:extLst>
+                <a:ext uri="{FF2B5EF4-FFF2-40B4-BE49-F238E27FC236}">
+                  <a16:creationId xmlns:a16="http://schemas.microsoft.com/office/drawing/2014/main" id="{9D360CEE-35E9-E7FD-1FAA-7757E42161FE}"/>
+                </a:ext>
+              </a:extLst>
+            </p:cNvPr>
+            <p:cNvSpPr/>
+            <p:nvPr/>
+          </p:nvSpPr>
+          <p:spPr>
+            <a:xfrm>
+              <a:off x="10450483" y="1865589"/>
+              <a:ext cx="194863" cy="394089"/>
+            </a:xfrm>
+            <a:prstGeom prst="lightningBolt">
+              <a:avLst/>
+            </a:prstGeom>
+          </p:spPr>
+          <p:style>
+            <a:lnRef idx="2">
+              <a:schemeClr val="accent1">
+                <a:shade val="50000"/>
+              </a:schemeClr>
+            </a:lnRef>
+            <a:fillRef idx="1">
+              <a:schemeClr val="accent1"/>
+            </a:fillRef>
+            <a:effectRef idx="0">
+              <a:schemeClr val="accent1"/>
+            </a:effectRef>
+            <a:fontRef idx="minor">
+              <a:schemeClr val="lt1"/>
+            </a:fontRef>
+          </p:style>
+          <p:txBody>
+            <a:bodyPr rtlCol="0" anchor="ctr"/>
+            <a:lstStyle/>
+            <a:p>
+              <a:pPr algn="ctr"/>
+              <a:endParaRPr lang="en-US"/>
+            </a:p>
+          </p:txBody>
+        </p:sp>
+        <p:sp>
+          <p:nvSpPr>
+            <p:cNvPr id="21" name="Rectangle 20">
+              <a:extLst>
+                <a:ext uri="{FF2B5EF4-FFF2-40B4-BE49-F238E27FC236}">
+                  <a16:creationId xmlns:a16="http://schemas.microsoft.com/office/drawing/2014/main" id="{7EE59DA4-66BC-1FE4-0007-7BB0A097227D}"/>
+                </a:ext>
+              </a:extLst>
+            </p:cNvPr>
+            <p:cNvSpPr/>
+            <p:nvPr/>
+          </p:nvSpPr>
+          <p:spPr>
+            <a:xfrm>
+              <a:off x="9434570" y="1690825"/>
+              <a:ext cx="1953880" cy="1768165"/>
+            </a:xfrm>
+            <a:prstGeom prst="rect">
+              <a:avLst/>
+            </a:prstGeom>
+            <a:solidFill>
+              <a:srgbClr val="4472C4">
+                <a:alpha val="10196"/>
+              </a:srgbClr>
+            </a:solidFill>
+          </p:spPr>
+          <p:style>
+            <a:lnRef idx="2">
+              <a:schemeClr val="accent1">
+                <a:shade val="50000"/>
+              </a:schemeClr>
+            </a:lnRef>
+            <a:fillRef idx="1">
+              <a:schemeClr val="accent1"/>
+            </a:fillRef>
+            <a:effectRef idx="0">
+              <a:schemeClr val="accent1"/>
+            </a:effectRef>
+            <a:fontRef idx="minor">
+              <a:schemeClr val="lt1"/>
+            </a:fontRef>
+          </p:style>
+          <p:txBody>
+            <a:bodyPr rtlCol="0" anchor="ctr"/>
+            <a:lstStyle/>
+            <a:p>
+              <a:pPr algn="ctr"/>
+              <a:endParaRPr lang="en-US"/>
+            </a:p>
+          </p:txBody>
+        </p:sp>
+      </p:grpSp>
+      <p:sp>
+        <p:nvSpPr>
+          <p:cNvPr id="23" name="Google Shape;466;ga2bd4a1cd8_0_91">
+            <a:extLst>
+              <a:ext uri="{FF2B5EF4-FFF2-40B4-BE49-F238E27FC236}">
+                <a16:creationId xmlns:a16="http://schemas.microsoft.com/office/drawing/2014/main" id="{A4EDABE8-06FA-9968-6C94-868AD09438C7}"/>
+              </a:ext>
+            </a:extLst>
+          </p:cNvPr>
+          <p:cNvSpPr/>
+          <p:nvPr/>
+        </p:nvSpPr>
+        <p:spPr>
+          <a:xfrm>
+            <a:off x="6365978" y="1016185"/>
+            <a:ext cx="1219200" cy="466500"/>
+          </a:xfrm>
+          <a:prstGeom prst="rect">
+            <a:avLst/>
+          </a:prstGeom>
+          <a:solidFill>
+            <a:srgbClr val="A4C2F4"/>
+          </a:solidFill>
+          <a:ln w="9525" cap="flat" cmpd="sng">
+            <a:solidFill>
+              <a:srgbClr val="000000"/>
+            </a:solidFill>
+            <a:prstDash val="solid"/>
+            <a:round/>
+            <a:headEnd type="none" w="sm" len="sm"/>
+            <a:tailEnd type="none" w="sm" len="sm"/>
+          </a:ln>
+        </p:spPr>
+        <p:txBody>
+          <a:bodyPr spcFirstLastPara="1" wrap="square" lIns="91425" tIns="91425" rIns="91425" bIns="91425" anchor="ctr" anchorCtr="0">
+            <a:noAutofit/>
+          </a:bodyPr>
+          <a:lstStyle/>
+          <a:p>
+            <a:pPr marL="0" lvl="0" indent="0" algn="ctr" rtl="0">
+              <a:spcBef>
+                <a:spcPts val="0"/>
+              </a:spcBef>
+              <a:spcAft>
+                <a:spcPts val="0"/>
+              </a:spcAft>
+              <a:buNone/>
+            </a:pPr>
+            <a:r>
+              <a:rPr lang="en-US" dirty="0"/>
+              <a:t>Alert GW Service</a:t>
+            </a:r>
+            <a:endParaRPr dirty="0"/>
+          </a:p>
+        </p:txBody>
+      </p:sp>
+      <p:cxnSp>
+        <p:nvCxnSpPr>
+          <p:cNvPr id="24" name="Straight Arrow Connector 23">
+            <a:extLst>
+              <a:ext uri="{FF2B5EF4-FFF2-40B4-BE49-F238E27FC236}">
+                <a16:creationId xmlns:a16="http://schemas.microsoft.com/office/drawing/2014/main" id="{CE4471B0-7DC2-A0BE-14A5-55B72484AC9C}"/>
+              </a:ext>
+            </a:extLst>
+          </p:cNvPr>
+          <p:cNvCxnSpPr>
+            <a:cxnSpLocks/>
+            <a:endCxn id="23" idx="2"/>
+          </p:cNvCxnSpPr>
+          <p:nvPr/>
+        </p:nvCxnSpPr>
+        <p:spPr>
+          <a:xfrm flipV="1">
+            <a:off x="6975578" y="1482685"/>
+            <a:ext cx="0" cy="297243"/>
+          </a:xfrm>
+          <a:prstGeom prst="straightConnector1">
+            <a:avLst/>
+          </a:prstGeom>
+          <a:ln w="34925">
+            <a:tailEnd type="triangle"/>
+          </a:ln>
+        </p:spPr>
+        <p:style>
+          <a:lnRef idx="1">
+            <a:schemeClr val="accent1"/>
+          </a:lnRef>
+          <a:fillRef idx="0">
+            <a:schemeClr val="accent1"/>
+          </a:fillRef>
+          <a:effectRef idx="0">
+            <a:schemeClr val="accent1"/>
+          </a:effectRef>
+          <a:fontRef idx="minor">
+            <a:schemeClr val="tx1"/>
+          </a:fontRef>
+        </p:style>
+      </p:cxnSp>
+      <p:cxnSp>
+        <p:nvCxnSpPr>
+          <p:cNvPr id="49" name="Straight Arrow Connector 48">
+            <a:extLst>
+              <a:ext uri="{FF2B5EF4-FFF2-40B4-BE49-F238E27FC236}">
+                <a16:creationId xmlns:a16="http://schemas.microsoft.com/office/drawing/2014/main" id="{AE41E3B4-3B37-5469-4934-1E9B09D05ED2}"/>
+              </a:ext>
+            </a:extLst>
+          </p:cNvPr>
+          <p:cNvCxnSpPr>
+            <a:cxnSpLocks/>
+            <a:endCxn id="7" idx="1"/>
+          </p:cNvCxnSpPr>
+          <p:nvPr/>
+        </p:nvCxnSpPr>
+        <p:spPr>
+          <a:xfrm flipV="1">
+            <a:off x="7585178" y="1253141"/>
+            <a:ext cx="464084" cy="6352"/>
+          </a:xfrm>
+          <a:prstGeom prst="straightConnector1">
+            <a:avLst/>
+          </a:prstGeom>
+          <a:ln w="34925">
+            <a:tailEnd type="triangle"/>
+          </a:ln>
+        </p:spPr>
+        <p:style>
+          <a:lnRef idx="1">
+            <a:schemeClr val="accent1"/>
+          </a:lnRef>
+          <a:fillRef idx="0">
+            <a:schemeClr val="accent1"/>
+          </a:fillRef>
+          <a:effectRef idx="0">
+            <a:schemeClr val="accent1"/>
+          </a:effectRef>
+          <a:fontRef idx="minor">
+            <a:schemeClr val="tx1"/>
+          </a:fontRef>
+        </p:style>
+      </p:cxnSp>
+      <p:cxnSp>
+        <p:nvCxnSpPr>
+          <p:cNvPr id="54" name="Google Shape;481;ga2bd4a1cd8_0_91">
+            <a:extLst>
+              <a:ext uri="{FF2B5EF4-FFF2-40B4-BE49-F238E27FC236}">
+                <a16:creationId xmlns:a16="http://schemas.microsoft.com/office/drawing/2014/main" id="{09E1D998-03BA-CC31-14E8-49ED0A204026}"/>
+              </a:ext>
+            </a:extLst>
+          </p:cNvPr>
+          <p:cNvCxnSpPr>
+            <a:cxnSpLocks/>
+          </p:cNvCxnSpPr>
+          <p:nvPr/>
+        </p:nvCxnSpPr>
+        <p:spPr>
+          <a:xfrm flipH="1" flipV="1">
+            <a:off x="3693110" y="3702662"/>
+            <a:ext cx="14134" cy="750707"/>
+          </a:xfrm>
+          <a:prstGeom prst="straightConnector1">
+            <a:avLst/>
+          </a:prstGeom>
+          <a:noFill/>
+          <a:ln w="28575" cap="flat" cmpd="sng">
+            <a:solidFill>
+              <a:srgbClr val="FF0000"/>
+            </a:solidFill>
+            <a:prstDash val="sysDot"/>
+            <a:round/>
+            <a:headEnd type="none" w="med" len="med"/>
+            <a:tailEnd type="none" w="med" len="med"/>
+          </a:ln>
+        </p:spPr>
+      </p:cxnSp>
+      <p:cxnSp>
+        <p:nvCxnSpPr>
+          <p:cNvPr id="60" name="Google Shape;481;ga2bd4a1cd8_0_91">
+            <a:extLst>
+              <a:ext uri="{FF2B5EF4-FFF2-40B4-BE49-F238E27FC236}">
+                <a16:creationId xmlns:a16="http://schemas.microsoft.com/office/drawing/2014/main" id="{1F159055-F266-6C4E-3450-08CB4FF7D99A}"/>
+              </a:ext>
+            </a:extLst>
+          </p:cNvPr>
+          <p:cNvCxnSpPr>
+            <a:cxnSpLocks/>
+          </p:cNvCxnSpPr>
+          <p:nvPr/>
+        </p:nvCxnSpPr>
+        <p:spPr>
+          <a:xfrm>
+            <a:off x="3715971" y="3702662"/>
+            <a:ext cx="2027017" cy="0"/>
+          </a:xfrm>
+          <a:prstGeom prst="straightConnector1">
+            <a:avLst/>
+          </a:prstGeom>
+          <a:noFill/>
+          <a:ln w="28575" cap="flat" cmpd="sng">
+            <a:solidFill>
+              <a:srgbClr val="FF0000"/>
+            </a:solidFill>
+            <a:prstDash val="sysDot"/>
+            <a:round/>
+            <a:headEnd type="none" w="med" len="med"/>
+            <a:tailEnd type="none" w="med" len="med"/>
+          </a:ln>
+        </p:spPr>
+      </p:cxnSp>
+      <p:cxnSp>
+        <p:nvCxnSpPr>
+          <p:cNvPr id="74" name="Google Shape;481;ga2bd4a1cd8_0_91">
+            <a:extLst>
+              <a:ext uri="{FF2B5EF4-FFF2-40B4-BE49-F238E27FC236}">
+                <a16:creationId xmlns:a16="http://schemas.microsoft.com/office/drawing/2014/main" id="{5EDA8B59-EB4F-AF8D-55B2-759CA76579C6}"/>
+              </a:ext>
+            </a:extLst>
+          </p:cNvPr>
+          <p:cNvCxnSpPr>
+            <a:cxnSpLocks/>
+          </p:cNvCxnSpPr>
+          <p:nvPr/>
+        </p:nvCxnSpPr>
+        <p:spPr>
+          <a:xfrm flipV="1">
+            <a:off x="6902563" y="1495707"/>
+            <a:ext cx="0" cy="271198"/>
+          </a:xfrm>
+          <a:prstGeom prst="straightConnector1">
+            <a:avLst/>
+          </a:prstGeom>
+          <a:noFill/>
+          <a:ln w="28575" cap="flat" cmpd="sng">
+            <a:solidFill>
+              <a:srgbClr val="FF0000"/>
+            </a:solidFill>
+            <a:prstDash val="sysDot"/>
+            <a:round/>
+            <a:headEnd type="none" w="med" len="med"/>
+            <a:tailEnd type="none" w="med" len="med"/>
+          </a:ln>
+        </p:spPr>
+      </p:cxnSp>
+      <p:cxnSp>
+        <p:nvCxnSpPr>
+          <p:cNvPr id="79" name="Google Shape;481;ga2bd4a1cd8_0_91">
+            <a:extLst>
+              <a:ext uri="{FF2B5EF4-FFF2-40B4-BE49-F238E27FC236}">
+                <a16:creationId xmlns:a16="http://schemas.microsoft.com/office/drawing/2014/main" id="{29AB0537-30AF-88A5-C7BB-6DFAFF6B6C44}"/>
+              </a:ext>
+            </a:extLst>
+          </p:cNvPr>
+          <p:cNvCxnSpPr>
+            <a:cxnSpLocks/>
+          </p:cNvCxnSpPr>
+          <p:nvPr/>
+        </p:nvCxnSpPr>
+        <p:spPr>
+          <a:xfrm flipH="1" flipV="1">
+            <a:off x="5737469" y="2913760"/>
+            <a:ext cx="14134" cy="750707"/>
+          </a:xfrm>
+          <a:prstGeom prst="straightConnector1">
+            <a:avLst/>
+          </a:prstGeom>
+          <a:noFill/>
+          <a:ln w="28575" cap="flat" cmpd="sng">
+            <a:solidFill>
+              <a:srgbClr val="FF0000"/>
+            </a:solidFill>
+            <a:prstDash val="sysDot"/>
+            <a:round/>
+            <a:headEnd type="none" w="med" len="med"/>
+            <a:tailEnd type="none" w="med" len="med"/>
+          </a:ln>
+        </p:spPr>
+      </p:cxnSp>
+      <p:cxnSp>
+        <p:nvCxnSpPr>
+          <p:cNvPr id="83" name="Google Shape;481;ga2bd4a1cd8_0_91">
+            <a:extLst>
+              <a:ext uri="{FF2B5EF4-FFF2-40B4-BE49-F238E27FC236}">
+                <a16:creationId xmlns:a16="http://schemas.microsoft.com/office/drawing/2014/main" id="{23AA0B95-A4E3-39C9-B391-AF1CDAF1863E}"/>
+              </a:ext>
+            </a:extLst>
+          </p:cNvPr>
+          <p:cNvCxnSpPr>
+            <a:cxnSpLocks/>
+          </p:cNvCxnSpPr>
+          <p:nvPr/>
+        </p:nvCxnSpPr>
+        <p:spPr>
+          <a:xfrm>
+            <a:off x="5737120" y="1715403"/>
+            <a:ext cx="1165443" cy="0"/>
+          </a:xfrm>
+          <a:prstGeom prst="straightConnector1">
+            <a:avLst/>
+          </a:prstGeom>
+          <a:noFill/>
+          <a:ln w="28575" cap="flat" cmpd="sng">
+            <a:solidFill>
+              <a:srgbClr val="FF0000"/>
+            </a:solidFill>
+            <a:prstDash val="sysDot"/>
+            <a:round/>
+            <a:headEnd type="none" w="med" len="med"/>
+            <a:tailEnd type="none" w="med" len="med"/>
+          </a:ln>
+        </p:spPr>
+      </p:cxnSp>
+      <p:sp>
+        <p:nvSpPr>
+          <p:cNvPr id="86" name="Google Shape;470;ga2bd4a1cd8_0_91">
+            <a:extLst>
+              <a:ext uri="{FF2B5EF4-FFF2-40B4-BE49-F238E27FC236}">
+                <a16:creationId xmlns:a16="http://schemas.microsoft.com/office/drawing/2014/main" id="{05140C13-5270-7A4E-F775-4EF22185F661}"/>
+              </a:ext>
+            </a:extLst>
+          </p:cNvPr>
+          <p:cNvSpPr/>
+          <p:nvPr/>
+        </p:nvSpPr>
+        <p:spPr>
+          <a:xfrm>
+            <a:off x="2066978" y="3180759"/>
+            <a:ext cx="823500" cy="466500"/>
+          </a:xfrm>
+          <a:prstGeom prst="rect">
+            <a:avLst/>
+          </a:prstGeom>
+          <a:solidFill>
+            <a:schemeClr val="tx2"/>
+          </a:solidFill>
+          <a:ln w="9525" cap="flat" cmpd="sng">
+            <a:solidFill>
+              <a:srgbClr val="000000"/>
+            </a:solidFill>
+            <a:prstDash val="solid"/>
+            <a:round/>
+            <a:headEnd type="none" w="sm" len="sm"/>
+            <a:tailEnd type="none" w="sm" len="sm"/>
+          </a:ln>
+        </p:spPr>
+        <p:txBody>
+          <a:bodyPr spcFirstLastPara="1" wrap="square" lIns="91425" tIns="91425" rIns="91425" bIns="91425" anchor="ctr" anchorCtr="0">
+            <a:noAutofit/>
+          </a:bodyPr>
+          <a:lstStyle/>
+          <a:p>
+            <a:pPr marL="0" lvl="0" indent="0" algn="ctr" rtl="0">
+              <a:spcBef>
+                <a:spcPts val="0"/>
+              </a:spcBef>
+              <a:spcAft>
+                <a:spcPts val="0"/>
+              </a:spcAft>
+              <a:buNone/>
+            </a:pPr>
+            <a:r>
+              <a:rPr lang="en-US" dirty="0"/>
+              <a:t>Pump</a:t>
+            </a:r>
+            <a:endParaRPr dirty="0"/>
+          </a:p>
+        </p:txBody>
+      </p:sp>
+      <p:cxnSp>
+        <p:nvCxnSpPr>
+          <p:cNvPr id="87" name="Google Shape;483;ga2bd4a1cd8_0_91">
+            <a:extLst>
+              <a:ext uri="{FF2B5EF4-FFF2-40B4-BE49-F238E27FC236}">
+                <a16:creationId xmlns:a16="http://schemas.microsoft.com/office/drawing/2014/main" id="{C2A277B9-821F-7076-6854-6768C3085B92}"/>
+              </a:ext>
+            </a:extLst>
+          </p:cNvPr>
+          <p:cNvCxnSpPr>
+            <a:cxnSpLocks/>
+          </p:cNvCxnSpPr>
+          <p:nvPr/>
+        </p:nvCxnSpPr>
+        <p:spPr>
+          <a:xfrm flipV="1">
+            <a:off x="2513290" y="3636648"/>
+            <a:ext cx="0" cy="145849"/>
+          </a:xfrm>
+          <a:prstGeom prst="straightConnector1">
+            <a:avLst/>
+          </a:prstGeom>
+          <a:noFill/>
+          <a:ln w="28575" cap="flat" cmpd="sng">
+            <a:solidFill>
+              <a:schemeClr val="dk2"/>
+            </a:solidFill>
+            <a:prstDash val="solid"/>
+            <a:round/>
+            <a:headEnd type="none" w="med" len="med"/>
+            <a:tailEnd type="none" w="med" len="med"/>
+          </a:ln>
+        </p:spPr>
+      </p:cxnSp>
     </p:spTree>
     <p:extLst>
       <p:ext uri="{BB962C8B-B14F-4D97-AF65-F5344CB8AC3E}">
-        <p14:creationId xmlns:p14="http://schemas.microsoft.com/office/powerpoint/2010/main" val="907362194"/>
+        <p14:creationId xmlns:p14="http://schemas.microsoft.com/office/powerpoint/2010/main" val="2618125408"/>
       </p:ext>
     </p:extLst>
   </p:cSld>

</xml_diff>